<commit_message>
Update 가라사대 assets and add ZIP slides
Co-Authored-By: Claude Opus 4.6 (1M context) <noreply@anthropic.com>
</commit_message>
<xml_diff>
--- a/public/downloads/games/simon-says/rules.pptx
+++ b/public/downloads/games/simon-says/rules.pptx
@@ -14,16 +14,12 @@
   <p:notesSz cx="6858000" cy="9144000"/>
   <p:embeddedFontLst>
     <p:embeddedFont>
-      <p:font typeface="Jua" charset="1" panose="00000000000000000000"/>
+      <p:font typeface="무궁화 고딕" charset="1" panose="02020603020101020101"/>
       <p:regular r:id="rId10"/>
     </p:embeddedFont>
     <p:embeddedFont>
-      <p:font typeface="TDTD갬성명조" charset="1" panose="02000503000000000000"/>
+      <p:font typeface="무궁화 고딕 Bold" charset="1" panose="02020603020101020101"/>
       <p:regular r:id="rId11"/>
-    </p:embeddedFont>
-    <p:embeddedFont>
-      <p:font typeface="TDTD가온" charset="1" panose="02000503000000000000"/>
-      <p:regular r:id="rId12"/>
     </p:embeddedFont>
   </p:embeddedFontLst>
   <p:defaultTextStyle>
@@ -3141,8 +3137,8 @@
         </p:nvSpPr>
         <p:spPr>
           <a:xfrm rot="0">
-            <a:off x="1028700" y="3892867"/>
-            <a:ext cx="15555091" cy="2200275"/>
+            <a:off x="1028700" y="4178617"/>
+            <a:ext cx="15555091" cy="1914525"/>
           </a:xfrm>
           <a:prstGeom prst="rect">
             <a:avLst/>
@@ -3164,10 +3160,10 @@
                 <a:solidFill>
                   <a:srgbClr val="FFFAEF"/>
                 </a:solidFill>
-                <a:latin typeface="Jua"/>
-                <a:ea typeface="Jua"/>
-                <a:cs typeface="Jua"/>
-                <a:sym typeface="Jua"/>
+                <a:latin typeface="무궁화 고딕"/>
+                <a:ea typeface="무궁화 고딕"/>
+                <a:cs typeface="무궁화 고딕"/>
+                <a:sym typeface="무궁화 고딕"/>
               </a:rPr>
               <a:t>가라사대</a:t>
             </a:r>
@@ -3182,8 +3178,8 @@
         </p:nvSpPr>
         <p:spPr>
           <a:xfrm rot="0">
-            <a:off x="15264803" y="9812655"/>
-            <a:ext cx="2637975" cy="474345"/>
+            <a:off x="14542909" y="9822180"/>
+            <a:ext cx="3359870" cy="464820"/>
           </a:xfrm>
           <a:prstGeom prst="rect">
             <a:avLst/>
@@ -3208,10 +3204,10 @@
                 <a:solidFill>
                   <a:srgbClr val="FFFFFF"/>
                 </a:solidFill>
-                <a:latin typeface="TDTD갬성명조"/>
-                <a:ea typeface="TDTD갬성명조"/>
-                <a:cs typeface="TDTD갬성명조"/>
-                <a:sym typeface="TDTD갬성명조"/>
+                <a:latin typeface="무궁화 고딕"/>
+                <a:ea typeface="무궁화 고딕"/>
+                <a:cs typeface="무궁화 고딕"/>
+                <a:sym typeface="무궁화 고딕"/>
               </a:rPr>
               <a:t>ⓒ 2026. Sunday Play</a:t>
             </a:r>
@@ -3360,8 +3356,8 @@
         </p:nvSpPr>
         <p:spPr>
           <a:xfrm rot="0">
-            <a:off x="11392761" y="600705"/>
-            <a:ext cx="5362043" cy="1600200"/>
+            <a:off x="11392761" y="819780"/>
+            <a:ext cx="5362043" cy="1381125"/>
           </a:xfrm>
           <a:prstGeom prst="rect">
             <a:avLst/>
@@ -3383,10 +3379,10 @@
                 <a:solidFill>
                   <a:srgbClr val="FFFAEF"/>
                 </a:solidFill>
-                <a:latin typeface="Jua"/>
-                <a:ea typeface="Jua"/>
-                <a:cs typeface="Jua"/>
-                <a:sym typeface="Jua"/>
+                <a:latin typeface="무궁화 고딕"/>
+                <a:ea typeface="무궁화 고딕"/>
+                <a:cs typeface="무궁화 고딕"/>
+                <a:sym typeface="무궁화 고딕"/>
               </a:rPr>
               <a:t>규칙</a:t>
             </a:r>
@@ -3402,9 +3398,9 @@
         <p:grpSpPr>
           <a:xfrm rot="0">
             <a:off x="309172" y="535073"/>
-            <a:ext cx="11933749" cy="2447614"/>
+            <a:ext cx="11933749" cy="2412054"/>
             <a:chOff x="0" y="0"/>
-            <a:chExt cx="15911666" cy="3263486"/>
+            <a:chExt cx="15911666" cy="3216072"/>
           </a:xfrm>
         </p:grpSpPr>
         <p:sp>
@@ -3415,8 +3411,8 @@
           </p:nvSpPr>
           <p:spPr>
             <a:xfrm rot="0">
-              <a:off x="0" y="1386214"/>
-              <a:ext cx="15911666" cy="1877272"/>
+              <a:off x="0" y="1395739"/>
+              <a:ext cx="15911666" cy="1820333"/>
             </a:xfrm>
             <a:prstGeom prst="rect">
               <a:avLst/>
@@ -3430,18 +3426,18 @@
             <a:p>
               <a:pPr algn="l">
                 <a:lnSpc>
-                  <a:spcPts val="5739"/>
+                  <a:spcPts val="5599"/>
                 </a:lnSpc>
               </a:pPr>
               <a:r>
-                <a:rPr lang="en-US" sz="4099">
+                <a:rPr lang="en-US" sz="3999">
                   <a:solidFill>
                     <a:srgbClr val="FFFAEF"/>
                   </a:solidFill>
-                  <a:latin typeface="TDTD가온"/>
-                  <a:ea typeface="TDTD가온"/>
-                  <a:cs typeface="TDTD가온"/>
-                  <a:sym typeface="TDTD가온"/>
+                  <a:latin typeface="무궁화 고딕"/>
+                  <a:ea typeface="무궁화 고딕"/>
+                  <a:cs typeface="무궁화 고딕"/>
+                  <a:sym typeface="무궁화 고딕"/>
                 </a:rPr>
                 <a:t>"가라사대"가 있는 행동만 따라합니다.</a:t>
               </a:r>
@@ -3449,18 +3445,18 @@
             <a:p>
               <a:pPr algn="l">
                 <a:lnSpc>
-                  <a:spcPts val="5739"/>
+                  <a:spcPts val="5599"/>
                 </a:lnSpc>
               </a:pPr>
               <a:r>
-                <a:rPr lang="en-US" sz="4099">
+                <a:rPr lang="en-US" sz="3999">
                   <a:solidFill>
                     <a:srgbClr val="FFFAEF"/>
                   </a:solidFill>
-                  <a:latin typeface="TDTD가온"/>
-                  <a:ea typeface="TDTD가온"/>
-                  <a:cs typeface="TDTD가온"/>
-                  <a:sym typeface="TDTD가온"/>
+                  <a:latin typeface="무궁화 고딕"/>
+                  <a:ea typeface="무궁화 고딕"/>
+                  <a:cs typeface="무궁화 고딕"/>
+                  <a:sym typeface="무궁화 고딕"/>
                 </a:rPr>
                 <a:t>(예: "가라사대 손 들어!")</a:t>
               </a:r>
@@ -3475,8 +3471,8 @@
           </p:nvSpPr>
           <p:spPr>
             <a:xfrm rot="0">
-              <a:off x="0" y="-161925"/>
-              <a:ext cx="10684245" cy="1111038"/>
+              <a:off x="0" y="-57150"/>
+              <a:ext cx="10684245" cy="1006263"/>
             </a:xfrm>
             <a:prstGeom prst="rect">
               <a:avLst/>
@@ -3498,10 +3494,10 @@
                   <a:solidFill>
                     <a:srgbClr val="FFFAEF"/>
                   </a:solidFill>
-                  <a:latin typeface="Jua"/>
-                  <a:ea typeface="Jua"/>
-                  <a:cs typeface="Jua"/>
-                  <a:sym typeface="Jua"/>
+                  <a:latin typeface="무궁화 고딕 Bold"/>
+                  <a:ea typeface="무궁화 고딕 Bold"/>
+                  <a:cs typeface="무궁화 고딕 Bold"/>
+                  <a:sym typeface="무궁화 고딕 Bold"/>
                 </a:rPr>
                 <a:t>STEP 1.</a:t>
               </a:r>
@@ -3517,10 +3513,10 @@
         </p:nvGrpSpPr>
         <p:grpSpPr>
           <a:xfrm rot="0">
-            <a:off x="9797745" y="7419270"/>
-            <a:ext cx="8552074" cy="2442751"/>
+            <a:off x="9797745" y="7539586"/>
+            <a:ext cx="8552074" cy="2407191"/>
             <a:chOff x="0" y="0"/>
-            <a:chExt cx="11402765" cy="3257001"/>
+            <a:chExt cx="11402765" cy="3209588"/>
           </a:xfrm>
         </p:grpSpPr>
         <p:sp>
@@ -3531,8 +3527,8 @@
           </p:nvSpPr>
           <p:spPr>
             <a:xfrm rot="0">
-              <a:off x="0" y="1379728"/>
-              <a:ext cx="11402765" cy="1877273"/>
+              <a:off x="0" y="1389253"/>
+              <a:ext cx="11402765" cy="1820334"/>
             </a:xfrm>
             <a:prstGeom prst="rect">
               <a:avLst/>
@@ -3546,30 +3542,30 @@
             <a:p>
               <a:pPr algn="l">
                 <a:lnSpc>
-                  <a:spcPts val="5739"/>
+                  <a:spcPts val="5599"/>
                 </a:lnSpc>
               </a:pPr>
               <a:r>
-                <a:rPr lang="en-US" sz="4099">
+                <a:rPr lang="en-US" sz="3999">
                   <a:solidFill>
                     <a:srgbClr val="FFFAEF"/>
                   </a:solidFill>
-                  <a:latin typeface="TDTD가온"/>
-                  <a:ea typeface="TDTD가온"/>
-                  <a:cs typeface="TDTD가온"/>
-                  <a:sym typeface="TDTD가온"/>
+                  <a:latin typeface="무궁화 고딕"/>
+                  <a:ea typeface="무궁화 고딕"/>
+                  <a:cs typeface="무궁화 고딕"/>
+                  <a:sym typeface="무궁화 고딕"/>
                 </a:rPr>
                 <a:t>잘못 움직이거나</a:t>
               </a:r>
               <a:r>
-                <a:rPr lang="en-US" sz="4099">
+                <a:rPr lang="en-US" sz="3999">
                   <a:solidFill>
                     <a:srgbClr val="FFFAEF"/>
                   </a:solidFill>
-                  <a:latin typeface="TDTD가온"/>
-                  <a:ea typeface="TDTD가온"/>
-                  <a:cs typeface="TDTD가온"/>
-                  <a:sym typeface="TDTD가온"/>
+                  <a:latin typeface="무궁화 고딕"/>
+                  <a:ea typeface="무궁화 고딕"/>
+                  <a:cs typeface="무궁화 고딕"/>
+                  <a:sym typeface="무궁화 고딕"/>
                 </a:rPr>
                 <a:t> 반응이 늦으면 즉시 탈락!</a:t>
               </a:r>
@@ -3577,18 +3573,18 @@
             <a:p>
               <a:pPr algn="l">
                 <a:lnSpc>
-                  <a:spcPts val="5739"/>
+                  <a:spcPts val="5599"/>
                 </a:lnSpc>
               </a:pPr>
               <a:r>
-                <a:rPr lang="en-US" sz="4099">
+                <a:rPr lang="en-US" sz="3999">
                   <a:solidFill>
                     <a:srgbClr val="FFFAEF"/>
                   </a:solidFill>
-                  <a:latin typeface="TDTD가온"/>
-                  <a:ea typeface="TDTD가온"/>
-                  <a:cs typeface="TDTD가온"/>
-                  <a:sym typeface="TDTD가온"/>
+                  <a:latin typeface="무궁화 고딕"/>
+                  <a:ea typeface="무궁화 고딕"/>
+                  <a:cs typeface="무궁화 고딕"/>
+                  <a:sym typeface="무궁화 고딕"/>
                 </a:rPr>
                 <a:t>최후의 1인이 남을때까지 진행합니다.</a:t>
               </a:r>
@@ -3603,8 +3599,8 @@
           </p:nvSpPr>
           <p:spPr>
             <a:xfrm rot="0">
-              <a:off x="0" y="-161925"/>
-              <a:ext cx="11402765" cy="1111039"/>
+              <a:off x="0" y="-57150"/>
+              <a:ext cx="11402765" cy="1006264"/>
             </a:xfrm>
             <a:prstGeom prst="rect">
               <a:avLst/>
@@ -3626,10 +3622,10 @@
                   <a:solidFill>
                     <a:srgbClr val="FFFAEF"/>
                   </a:solidFill>
-                  <a:latin typeface="Jua"/>
-                  <a:ea typeface="Jua"/>
-                  <a:cs typeface="Jua"/>
-                  <a:sym typeface="Jua"/>
+                  <a:latin typeface="무궁화 고딕 Bold"/>
+                  <a:ea typeface="무궁화 고딕 Bold"/>
+                  <a:cs typeface="무궁화 고딕 Bold"/>
+                  <a:sym typeface="무궁화 고딕 Bold"/>
                 </a:rPr>
                 <a:t>STEP 3.</a:t>
               </a:r>
@@ -3645,10 +3641,10 @@
         </p:nvGrpSpPr>
         <p:grpSpPr>
           <a:xfrm rot="0">
-            <a:off x="3910515" y="3922125"/>
-            <a:ext cx="10466970" cy="2442750"/>
+            <a:off x="3910515" y="3975465"/>
+            <a:ext cx="10466970" cy="2336070"/>
             <a:chOff x="0" y="0"/>
-            <a:chExt cx="13955960" cy="3257001"/>
+            <a:chExt cx="13955960" cy="3114760"/>
           </a:xfrm>
         </p:grpSpPr>
         <p:sp>
@@ -3660,7 +3656,7 @@
           <p:spPr>
             <a:xfrm rot="0">
               <a:off x="0" y="1379728"/>
-              <a:ext cx="13955960" cy="1877273"/>
+              <a:ext cx="13955960" cy="1735033"/>
             </a:xfrm>
             <a:prstGeom prst="rect">
               <a:avLst/>
@@ -3674,30 +3670,30 @@
             <a:p>
               <a:pPr algn="l">
                 <a:lnSpc>
-                  <a:spcPts val="5739"/>
+                  <a:spcPts val="5319"/>
                 </a:lnSpc>
               </a:pPr>
               <a:r>
-                <a:rPr lang="en-US" sz="4099">
+                <a:rPr lang="en-US" sz="3799">
                   <a:solidFill>
                     <a:srgbClr val="FFFAEF"/>
                   </a:solidFill>
-                  <a:latin typeface="TDTD가온"/>
-                  <a:ea typeface="TDTD가온"/>
-                  <a:cs typeface="TDTD가온"/>
-                  <a:sym typeface="TDTD가온"/>
+                  <a:latin typeface="무궁화 고딕"/>
+                  <a:ea typeface="무궁화 고딕"/>
+                  <a:cs typeface="무궁화 고딕"/>
+                  <a:sym typeface="무궁화 고딕"/>
                 </a:rPr>
                 <a:t>"가라사대" 없는 행동에는</a:t>
               </a:r>
               <a:r>
-                <a:rPr lang="en-US" sz="4099">
+                <a:rPr lang="en-US" sz="3799">
                   <a:solidFill>
                     <a:srgbClr val="FFFAEF"/>
                   </a:solidFill>
-                  <a:latin typeface="TDTD가온"/>
-                  <a:ea typeface="TDTD가온"/>
-                  <a:cs typeface="TDTD가온"/>
-                  <a:sym typeface="TDTD가온"/>
+                  <a:latin typeface="무궁화 고딕"/>
+                  <a:ea typeface="무궁화 고딕"/>
+                  <a:cs typeface="무궁화 고딕"/>
+                  <a:sym typeface="무궁화 고딕"/>
                 </a:rPr>
                 <a:t> 절대로 움직이지 않습니다.</a:t>
               </a:r>
@@ -3705,18 +3701,18 @@
             <a:p>
               <a:pPr algn="l">
                 <a:lnSpc>
-                  <a:spcPts val="5739"/>
+                  <a:spcPts val="5319"/>
                 </a:lnSpc>
               </a:pPr>
               <a:r>
-                <a:rPr lang="en-US" sz="4099">
+                <a:rPr lang="en-US" sz="3799">
                   <a:solidFill>
                     <a:srgbClr val="FFFAEF"/>
                   </a:solidFill>
-                  <a:latin typeface="TDTD가온"/>
-                  <a:ea typeface="TDTD가온"/>
-                  <a:cs typeface="TDTD가온"/>
-                  <a:sym typeface="TDTD가온"/>
+                  <a:latin typeface="무궁화 고딕"/>
+                  <a:ea typeface="무궁화 고딕"/>
+                  <a:cs typeface="무궁화 고딕"/>
+                  <a:sym typeface="무궁화 고딕"/>
                 </a:rPr>
                 <a:t>(예: "손 내려!" → 움직이면 탈락)</a:t>
               </a:r>
@@ -3731,8 +3727,8 @@
           </p:nvSpPr>
           <p:spPr>
             <a:xfrm rot="0">
-              <a:off x="0" y="-161925"/>
-              <a:ext cx="10551700" cy="1111038"/>
+              <a:off x="0" y="-57150"/>
+              <a:ext cx="10551700" cy="1006263"/>
             </a:xfrm>
             <a:prstGeom prst="rect">
               <a:avLst/>
@@ -3754,10 +3750,10 @@
                   <a:solidFill>
                     <a:srgbClr val="FFFAEF"/>
                   </a:solidFill>
-                  <a:latin typeface="Jua"/>
-                  <a:ea typeface="Jua"/>
-                  <a:cs typeface="Jua"/>
-                  <a:sym typeface="Jua"/>
+                  <a:latin typeface="무궁화 고딕 Bold"/>
+                  <a:ea typeface="무궁화 고딕 Bold"/>
+                  <a:cs typeface="무궁화 고딕 Bold"/>
+                  <a:sym typeface="무궁화 고딕 Bold"/>
                 </a:rPr>
                 <a:t>STEP 2.</a:t>
               </a:r>
@@ -3855,8 +3851,8 @@
         </p:nvSpPr>
         <p:spPr>
           <a:xfrm rot="0">
-            <a:off x="1028700" y="3892867"/>
-            <a:ext cx="15555091" cy="2200275"/>
+            <a:off x="1028700" y="4178617"/>
+            <a:ext cx="15555091" cy="1914525"/>
           </a:xfrm>
           <a:prstGeom prst="rect">
             <a:avLst/>
@@ -3878,10 +3874,10 @@
                 <a:solidFill>
                   <a:srgbClr val="FFFAEF"/>
                 </a:solidFill>
-                <a:latin typeface="Jua"/>
-                <a:ea typeface="Jua"/>
-                <a:cs typeface="Jua"/>
-                <a:sym typeface="Jua"/>
+                <a:latin typeface="무궁화 고딕"/>
+                <a:ea typeface="무궁화 고딕"/>
+                <a:cs typeface="무궁화 고딕"/>
+                <a:sym typeface="무궁화 고딕"/>
               </a:rPr>
               <a:t>가라사대</a:t>
             </a:r>
@@ -3896,8 +3892,8 @@
         </p:nvSpPr>
         <p:spPr>
           <a:xfrm rot="0">
-            <a:off x="15264803" y="9812655"/>
-            <a:ext cx="2637975" cy="474345"/>
+            <a:off x="14542909" y="9822180"/>
+            <a:ext cx="3359870" cy="464820"/>
           </a:xfrm>
           <a:prstGeom prst="rect">
             <a:avLst/>
@@ -3922,10 +3918,10 @@
                 <a:solidFill>
                   <a:srgbClr val="FFFFFF"/>
                 </a:solidFill>
-                <a:latin typeface="TDTD갬성명조"/>
-                <a:ea typeface="TDTD갬성명조"/>
-                <a:cs typeface="TDTD갬성명조"/>
-                <a:sym typeface="TDTD갬성명조"/>
+                <a:latin typeface="무궁화 고딕"/>
+                <a:ea typeface="무궁화 고딕"/>
+                <a:cs typeface="무궁화 고딕"/>
+                <a:sym typeface="무궁화 고딕"/>
               </a:rPr>
               <a:t>ⓒ 2026. Sunday Play</a:t>
             </a:r>
@@ -3997,8 +3993,8 @@
         </p:nvSpPr>
         <p:spPr>
           <a:xfrm rot="0">
-            <a:off x="4421807" y="3895725"/>
-            <a:ext cx="9444385" cy="2200275"/>
+            <a:off x="4421807" y="4181475"/>
+            <a:ext cx="9444385" cy="1914525"/>
           </a:xfrm>
           <a:prstGeom prst="rect">
             <a:avLst/>
@@ -4020,10 +4016,10 @@
                 <a:solidFill>
                   <a:srgbClr val="000000"/>
                 </a:solidFill>
-                <a:latin typeface="Jua"/>
-                <a:ea typeface="Jua"/>
-                <a:cs typeface="Jua"/>
-                <a:sym typeface="Jua"/>
+                <a:latin typeface="무궁화 고딕"/>
+                <a:ea typeface="무궁화 고딕"/>
+                <a:cs typeface="무궁화 고딕"/>
+                <a:sym typeface="무궁화 고딕"/>
               </a:rPr>
               <a:t>감사합니다!</a:t>
             </a:r>

</xml_diff>